<commit_message>
Update final report files and figures for version 15
- Changed the markdown file reference in generate-final.js from 'final-report-v14.md' to 'final-report-v15.md'.
- Updated multiple figures in the '06-final-report/figures' directory, including PPTX and PNG files, indicating changes in their binary content.
- Modified the generate-final-figures.js script to reflect changes in the system architecture diagram, including the integration of the Rate Limiter into the API layer.
- Adjusted text in the figures and HTML representations to ensure consistency with the updated architecture.
- Added a new snapshot of the final report document in the specified directory.
</commit_message>
<xml_diff>
--- a/06-final-report/figures/fig-2-system-architecture.pptx
+++ b/06-final-report/figures/fig-2-system-architecture.pptx
@@ -915,8 +915,8 @@
         </p:nvSpPr>
         <p:spPr>
           <a:xfrm>
-            <a:off x="457200" y="640080"/>
-            <a:ext cx="8229600" cy="685800"/>
+            <a:off x="457200" y="685800"/>
+            <a:ext cx="8229600" cy="731520"/>
           </a:xfrm>
           <a:prstGeom prst="rect">
             <a:avLst/>
@@ -940,7 +940,7 @@
         </p:nvSpPr>
         <p:spPr>
           <a:xfrm>
-            <a:off x="640080" y="685800"/>
+            <a:off x="640080" y="740664"/>
             <a:ext cx="2560320" cy="274320"/>
           </a:xfrm>
           <a:prstGeom prst="rect">
@@ -979,8 +979,8 @@
         </p:nvSpPr>
         <p:spPr>
           <a:xfrm>
-            <a:off x="3040380" y="868680"/>
-            <a:ext cx="2560320" cy="347472"/>
+            <a:off x="3282696" y="941832"/>
+            <a:ext cx="2377440" cy="384048"/>
           </a:xfrm>
           <a:prstGeom prst="rect">
             <a:avLst/>
@@ -1004,8 +1004,8 @@
         </p:nvSpPr>
         <p:spPr>
           <a:xfrm>
-            <a:off x="3040380" y="868680"/>
-            <a:ext cx="2560320" cy="347472"/>
+            <a:off x="3282696" y="941832"/>
+            <a:ext cx="2377440" cy="384048"/>
           </a:xfrm>
           <a:prstGeom prst="rect">
             <a:avLst/>
@@ -1043,8 +1043,8 @@
         </p:nvSpPr>
         <p:spPr>
           <a:xfrm>
-            <a:off x="5737860" y="868680"/>
-            <a:ext cx="2560320" cy="347472"/>
+            <a:off x="5769864" y="941832"/>
+            <a:ext cx="2377440" cy="384048"/>
           </a:xfrm>
           <a:prstGeom prst="rect">
             <a:avLst/>
@@ -1068,8 +1068,8 @@
         </p:nvSpPr>
         <p:spPr>
           <a:xfrm>
-            <a:off x="5737860" y="868680"/>
-            <a:ext cx="2560320" cy="347472"/>
+            <a:off x="5769864" y="941832"/>
+            <a:ext cx="2377440" cy="384048"/>
           </a:xfrm>
           <a:prstGeom prst="rect">
             <a:avLst/>
@@ -1107,8 +1107,8 @@
         </p:nvSpPr>
         <p:spPr>
           <a:xfrm>
-            <a:off x="457200" y="1463040"/>
-            <a:ext cx="8229600" cy="685800"/>
+            <a:off x="457200" y="1783080"/>
+            <a:ext cx="8229600" cy="731520"/>
           </a:xfrm>
           <a:prstGeom prst="rect">
             <a:avLst/>
@@ -1132,7 +1132,7 @@
         </p:nvSpPr>
         <p:spPr>
           <a:xfrm>
-            <a:off x="640080" y="1508760"/>
+            <a:off x="640080" y="1837944"/>
             <a:ext cx="2560320" cy="274320"/>
           </a:xfrm>
           <a:prstGeom prst="rect">
@@ -1157,7 +1157,7 @@
                 <a:ea typeface="맑은 고딕" pitchFamily="34" charset="-122"/>
                 <a:cs typeface="맑은 고딕" pitchFamily="34" charset="-120"/>
               </a:rPr>
-              <a:t>API 계층 (Express.js)</a:t>
+              <a:t>API 계층 (Express.js + Rate Limiter)</a:t>
             </a:r>
             <a:endParaRPr lang="en-US" sz="1000" dirty="0"/>
           </a:p>
@@ -1171,8 +1171,8 @@
         </p:nvSpPr>
         <p:spPr>
           <a:xfrm>
-            <a:off x="2651760" y="1691640"/>
-            <a:ext cx="1920240" cy="347472"/>
+            <a:off x="2715768" y="2039112"/>
+            <a:ext cx="1417320" cy="384048"/>
           </a:xfrm>
           <a:prstGeom prst="rect">
             <a:avLst/>
@@ -1196,8 +1196,8 @@
         </p:nvSpPr>
         <p:spPr>
           <a:xfrm>
-            <a:off x="2651760" y="1691640"/>
-            <a:ext cx="1920240" cy="347472"/>
+            <a:off x="2715768" y="2039112"/>
+            <a:ext cx="1417320" cy="384048"/>
           </a:xfrm>
           <a:prstGeom prst="rect">
             <a:avLst/>
@@ -1235,8 +1235,8 @@
         </p:nvSpPr>
         <p:spPr>
           <a:xfrm>
-            <a:off x="4709160" y="1691640"/>
-            <a:ext cx="1920240" cy="347472"/>
+            <a:off x="4242816" y="2039112"/>
+            <a:ext cx="1417320" cy="384048"/>
           </a:xfrm>
           <a:prstGeom prst="rect">
             <a:avLst/>
@@ -1260,8 +1260,8 @@
         </p:nvSpPr>
         <p:spPr>
           <a:xfrm>
-            <a:off x="4709160" y="1691640"/>
-            <a:ext cx="1920240" cy="347472"/>
+            <a:off x="4242816" y="2039112"/>
+            <a:ext cx="1417320" cy="384048"/>
           </a:xfrm>
           <a:prstGeom prst="rect">
             <a:avLst/>
@@ -1299,8 +1299,8 @@
         </p:nvSpPr>
         <p:spPr>
           <a:xfrm>
-            <a:off x="6766560" y="1691640"/>
-            <a:ext cx="1920240" cy="347472"/>
+            <a:off x="5769864" y="2039112"/>
+            <a:ext cx="1417320" cy="384048"/>
           </a:xfrm>
           <a:prstGeom prst="rect">
             <a:avLst/>
@@ -1324,8 +1324,8 @@
         </p:nvSpPr>
         <p:spPr>
           <a:xfrm>
-            <a:off x="6766560" y="1691640"/>
-            <a:ext cx="1920240" cy="347472"/>
+            <a:off x="5769864" y="2039112"/>
+            <a:ext cx="1417320" cy="384048"/>
           </a:xfrm>
           <a:prstGeom prst="rect">
             <a:avLst/>
@@ -1363,16 +1363,16 @@
         </p:nvSpPr>
         <p:spPr>
           <a:xfrm>
-            <a:off x="457200" y="2286000"/>
-            <a:ext cx="8229600" cy="685800"/>
-          </a:xfrm>
-          <a:prstGeom prst="rect">
-            <a:avLst/>
-          </a:prstGeom>
-          <a:solidFill>
-            <a:srgbClr val="FFFFFF"/>
-          </a:solidFill>
-          <a:ln w="9525">
+            <a:off x="7296912" y="2039112"/>
+            <a:ext cx="1417320" cy="384048"/>
+          </a:xfrm>
+          <a:prstGeom prst="rect">
+            <a:avLst/>
+          </a:prstGeom>
+          <a:solidFill>
+            <a:srgbClr val="F5F5F5"/>
+          </a:solidFill>
+          <a:ln w="12700">
             <a:solidFill>
               <a:srgbClr val="1F3A5F"/>
             </a:solidFill>
@@ -1388,8 +1388,8 @@
         </p:nvSpPr>
         <p:spPr>
           <a:xfrm>
-            <a:off x="640080" y="2331720"/>
-            <a:ext cx="2560320" cy="274320"/>
+            <a:off x="7296912" y="2039112"/>
+            <a:ext cx="1417320" cy="384048"/>
           </a:xfrm>
           <a:prstGeom prst="rect">
             <a:avLst/>
@@ -1401,11 +1401,11 @@
           <a:bodyPr wrap="square" rtlCol="0" anchor="ctr"/>
           <a:lstStyle/>
           <a:p>
-            <a:pPr indent="0" marL="0">
+            <a:pPr algn="ctr" indent="0" marL="0">
               <a:buNone/>
             </a:pPr>
             <a:r>
-              <a:rPr lang="en-US" sz="1000" b="1" dirty="0">
+              <a:rPr lang="en-US" sz="800" b="1" dirty="0">
                 <a:solidFill>
                   <a:srgbClr val="000000"/>
                 </a:solidFill>
@@ -1413,9 +1413,9 @@
                 <a:ea typeface="맑은 고딕" pitchFamily="34" charset="-122"/>
                 <a:cs typeface="맑은 고딕" pitchFamily="34" charset="-120"/>
               </a:rPr>
-              <a:t>요청 제한 계층 (Rate Limiter)</a:t>
-            </a:r>
-            <a:endParaRPr lang="en-US" sz="1000" dirty="0"/>
+              <a:t>Rate Limiter (구독 등급·429 응답)</a:t>
+            </a:r>
+            <a:endParaRPr lang="en-US" sz="800" dirty="0"/>
           </a:p>
         </p:txBody>
       </p:sp>
@@ -1427,16 +1427,16 @@
         </p:nvSpPr>
         <p:spPr>
           <a:xfrm>
-            <a:off x="2651760" y="2514600"/>
-            <a:ext cx="1920240" cy="347472"/>
-          </a:xfrm>
-          <a:prstGeom prst="rect">
-            <a:avLst/>
-          </a:prstGeom>
-          <a:solidFill>
-            <a:srgbClr val="F5F5F5"/>
-          </a:solidFill>
-          <a:ln w="6350">
+            <a:off x="457200" y="2880360"/>
+            <a:ext cx="8229600" cy="731520"/>
+          </a:xfrm>
+          <a:prstGeom prst="rect">
+            <a:avLst/>
+          </a:prstGeom>
+          <a:solidFill>
+            <a:srgbClr val="FFFFFF"/>
+          </a:solidFill>
+          <a:ln w="9525">
             <a:solidFill>
               <a:srgbClr val="000000"/>
             </a:solidFill>
@@ -1452,199 +1452,7 @@
         </p:nvSpPr>
         <p:spPr>
           <a:xfrm>
-            <a:off x="2651760" y="2514600"/>
-            <a:ext cx="1920240" cy="347472"/>
-          </a:xfrm>
-          <a:prstGeom prst="rect">
-            <a:avLst/>
-          </a:prstGeom>
-          <a:noFill/>
-          <a:ln/>
-        </p:spPr>
-        <p:txBody>
-          <a:bodyPr wrap="square" rtlCol="0" anchor="ctr"/>
-          <a:lstStyle/>
-          <a:p>
-            <a:pPr algn="ctr" indent="0" marL="0">
-              <a:buNone/>
-            </a:pPr>
-            <a:r>
-              <a:rPr lang="en-US" sz="900" dirty="0">
-                <a:solidFill>
-                  <a:srgbClr val="000000"/>
-                </a:solidFill>
-                <a:latin typeface="맑은 고딕" pitchFamily="34" charset="0"/>
-                <a:ea typeface="맑은 고딕" pitchFamily="34" charset="-122"/>
-                <a:cs typeface="맑은 고딕" pitchFamily="34" charset="-120"/>
-              </a:rPr>
-              <a:t>구독 등급 확인</a:t>
-            </a:r>
-            <a:endParaRPr lang="en-US" sz="900" dirty="0"/>
-          </a:p>
-        </p:txBody>
-      </p:sp>
-      <p:sp>
-        <p:nvSpPr>
-          <p:cNvPr id="21" name="Shape 19"/>
-          <p:cNvSpPr/>
-          <p:nvPr/>
-        </p:nvSpPr>
-        <p:spPr>
-          <a:xfrm>
-            <a:off x="4709160" y="2514600"/>
-            <a:ext cx="1920240" cy="347472"/>
-          </a:xfrm>
-          <a:prstGeom prst="rect">
-            <a:avLst/>
-          </a:prstGeom>
-          <a:solidFill>
-            <a:srgbClr val="F5F5F5"/>
-          </a:solidFill>
-          <a:ln w="6350">
-            <a:solidFill>
-              <a:srgbClr val="000000"/>
-            </a:solidFill>
-            <a:prstDash val="solid"/>
-          </a:ln>
-        </p:spPr>
-      </p:sp>
-      <p:sp>
-        <p:nvSpPr>
-          <p:cNvPr id="22" name="Text 20"/>
-          <p:cNvSpPr/>
-          <p:nvPr/>
-        </p:nvSpPr>
-        <p:spPr>
-          <a:xfrm>
-            <a:off x="4709160" y="2514600"/>
-            <a:ext cx="1920240" cy="347472"/>
-          </a:xfrm>
-          <a:prstGeom prst="rect">
-            <a:avLst/>
-          </a:prstGeom>
-          <a:noFill/>
-          <a:ln/>
-        </p:spPr>
-        <p:txBody>
-          <a:bodyPr wrap="square" rtlCol="0" anchor="ctr"/>
-          <a:lstStyle/>
-          <a:p>
-            <a:pPr algn="ctr" indent="0" marL="0">
-              <a:buNone/>
-            </a:pPr>
-            <a:r>
-              <a:rPr lang="en-US" sz="900" dirty="0">
-                <a:solidFill>
-                  <a:srgbClr val="000000"/>
-                </a:solidFill>
-                <a:latin typeface="맑은 고딕" pitchFamily="34" charset="0"/>
-                <a:ea typeface="맑은 고딕" pitchFamily="34" charset="-122"/>
-                <a:cs typeface="맑은 고딕" pitchFamily="34" charset="-120"/>
-              </a:rPr>
-              <a:t>토큰 버킷 제어</a:t>
-            </a:r>
-            <a:endParaRPr lang="en-US" sz="900" dirty="0"/>
-          </a:p>
-        </p:txBody>
-      </p:sp>
-      <p:sp>
-        <p:nvSpPr>
-          <p:cNvPr id="23" name="Shape 21"/>
-          <p:cNvSpPr/>
-          <p:nvPr/>
-        </p:nvSpPr>
-        <p:spPr>
-          <a:xfrm>
-            <a:off x="6766560" y="2514600"/>
-            <a:ext cx="1920240" cy="347472"/>
-          </a:xfrm>
-          <a:prstGeom prst="rect">
-            <a:avLst/>
-          </a:prstGeom>
-          <a:solidFill>
-            <a:srgbClr val="F5F5F5"/>
-          </a:solidFill>
-          <a:ln w="6350">
-            <a:solidFill>
-              <a:srgbClr val="000000"/>
-            </a:solidFill>
-            <a:prstDash val="solid"/>
-          </a:ln>
-        </p:spPr>
-      </p:sp>
-      <p:sp>
-        <p:nvSpPr>
-          <p:cNvPr id="24" name="Text 22"/>
-          <p:cNvSpPr/>
-          <p:nvPr/>
-        </p:nvSpPr>
-        <p:spPr>
-          <a:xfrm>
-            <a:off x="6766560" y="2514600"/>
-            <a:ext cx="1920240" cy="347472"/>
-          </a:xfrm>
-          <a:prstGeom prst="rect">
-            <a:avLst/>
-          </a:prstGeom>
-          <a:noFill/>
-          <a:ln/>
-        </p:spPr>
-        <p:txBody>
-          <a:bodyPr wrap="square" rtlCol="0" anchor="ctr"/>
-          <a:lstStyle/>
-          <a:p>
-            <a:pPr algn="ctr" indent="0" marL="0">
-              <a:buNone/>
-            </a:pPr>
-            <a:r>
-              <a:rPr lang="en-US" sz="900" dirty="0">
-                <a:solidFill>
-                  <a:srgbClr val="000000"/>
-                </a:solidFill>
-                <a:latin typeface="맑은 고딕" pitchFamily="34" charset="0"/>
-                <a:ea typeface="맑은 고딕" pitchFamily="34" charset="-122"/>
-                <a:cs typeface="맑은 고딕" pitchFamily="34" charset="-120"/>
-              </a:rPr>
-              <a:t>429 응답</a:t>
-            </a:r>
-            <a:endParaRPr lang="en-US" sz="900" dirty="0"/>
-          </a:p>
-        </p:txBody>
-      </p:sp>
-      <p:sp>
-        <p:nvSpPr>
-          <p:cNvPr id="25" name="Shape 23"/>
-          <p:cNvSpPr/>
-          <p:nvPr/>
-        </p:nvSpPr>
-        <p:spPr>
-          <a:xfrm>
-            <a:off x="457200" y="3108960"/>
-            <a:ext cx="8229600" cy="685800"/>
-          </a:xfrm>
-          <a:prstGeom prst="rect">
-            <a:avLst/>
-          </a:prstGeom>
-          <a:solidFill>
-            <a:srgbClr val="FFFFFF"/>
-          </a:solidFill>
-          <a:ln w="9525">
-            <a:solidFill>
-              <a:srgbClr val="000000"/>
-            </a:solidFill>
-            <a:prstDash val="solid"/>
-          </a:ln>
-        </p:spPr>
-      </p:sp>
-      <p:sp>
-        <p:nvSpPr>
-          <p:cNvPr id="26" name="Text 24"/>
-          <p:cNvSpPr/>
-          <p:nvPr/>
-        </p:nvSpPr>
-        <p:spPr>
-          <a:xfrm>
-            <a:off x="640080" y="3154680"/>
+            <a:off x="640080" y="2935224"/>
             <a:ext cx="2560320" cy="274320"/>
           </a:xfrm>
           <a:prstGeom prst="rect">
@@ -1677,14 +1485,14 @@
       </p:sp>
       <p:sp>
         <p:nvSpPr>
-          <p:cNvPr id="27" name="Shape 25"/>
-          <p:cNvSpPr/>
-          <p:nvPr/>
-        </p:nvSpPr>
-        <p:spPr>
-          <a:xfrm>
-            <a:off x="2446020" y="3337560"/>
-            <a:ext cx="1508760" cy="347472"/>
+          <p:cNvPr id="21" name="Shape 19"/>
+          <p:cNvSpPr/>
+          <p:nvPr/>
+        </p:nvSpPr>
+        <p:spPr>
+          <a:xfrm>
+            <a:off x="2715768" y="3136392"/>
+            <a:ext cx="1417320" cy="384048"/>
           </a:xfrm>
           <a:prstGeom prst="rect">
             <a:avLst/>
@@ -1702,14 +1510,14 @@
       </p:sp>
       <p:sp>
         <p:nvSpPr>
-          <p:cNvPr id="28" name="Text 26"/>
-          <p:cNvSpPr/>
-          <p:nvPr/>
-        </p:nvSpPr>
-        <p:spPr>
-          <a:xfrm>
-            <a:off x="2446020" y="3337560"/>
-            <a:ext cx="1508760" cy="347472"/>
+          <p:cNvPr id="22" name="Text 20"/>
+          <p:cNvSpPr/>
+          <p:nvPr/>
+        </p:nvSpPr>
+        <p:spPr>
+          <a:xfrm>
+            <a:off x="2715768" y="3136392"/>
+            <a:ext cx="1417320" cy="384048"/>
           </a:xfrm>
           <a:prstGeom prst="rect">
             <a:avLst/>
@@ -1741,14 +1549,14 @@
       </p:sp>
       <p:sp>
         <p:nvSpPr>
-          <p:cNvPr id="29" name="Shape 27"/>
-          <p:cNvSpPr/>
-          <p:nvPr/>
-        </p:nvSpPr>
-        <p:spPr>
-          <a:xfrm>
-            <a:off x="4091940" y="3337560"/>
-            <a:ext cx="1508760" cy="347472"/>
+          <p:cNvPr id="23" name="Shape 21"/>
+          <p:cNvSpPr/>
+          <p:nvPr/>
+        </p:nvSpPr>
+        <p:spPr>
+          <a:xfrm>
+            <a:off x="4242816" y="3136392"/>
+            <a:ext cx="1417320" cy="384048"/>
           </a:xfrm>
           <a:prstGeom prst="rect">
             <a:avLst/>
@@ -1766,14 +1574,14 @@
       </p:sp>
       <p:sp>
         <p:nvSpPr>
-          <p:cNvPr id="30" name="Text 28"/>
-          <p:cNvSpPr/>
-          <p:nvPr/>
-        </p:nvSpPr>
-        <p:spPr>
-          <a:xfrm>
-            <a:off x="4091940" y="3337560"/>
-            <a:ext cx="1508760" cy="347472"/>
+          <p:cNvPr id="24" name="Text 22"/>
+          <p:cNvSpPr/>
+          <p:nvPr/>
+        </p:nvSpPr>
+        <p:spPr>
+          <a:xfrm>
+            <a:off x="4242816" y="3136392"/>
+            <a:ext cx="1417320" cy="384048"/>
           </a:xfrm>
           <a:prstGeom prst="rect">
             <a:avLst/>
@@ -1805,14 +1613,14 @@
       </p:sp>
       <p:sp>
         <p:nvSpPr>
-          <p:cNvPr id="31" name="Shape 29"/>
-          <p:cNvSpPr/>
-          <p:nvPr/>
-        </p:nvSpPr>
-        <p:spPr>
-          <a:xfrm>
-            <a:off x="5737860" y="3337560"/>
-            <a:ext cx="1508760" cy="347472"/>
+          <p:cNvPr id="25" name="Shape 23"/>
+          <p:cNvSpPr/>
+          <p:nvPr/>
+        </p:nvSpPr>
+        <p:spPr>
+          <a:xfrm>
+            <a:off x="5769864" y="3136392"/>
+            <a:ext cx="1417320" cy="384048"/>
           </a:xfrm>
           <a:prstGeom prst="rect">
             <a:avLst/>
@@ -1830,14 +1638,14 @@
       </p:sp>
       <p:sp>
         <p:nvSpPr>
-          <p:cNvPr id="32" name="Text 30"/>
-          <p:cNvSpPr/>
-          <p:nvPr/>
-        </p:nvSpPr>
-        <p:spPr>
-          <a:xfrm>
-            <a:off x="5737860" y="3337560"/>
-            <a:ext cx="1508760" cy="347472"/>
+          <p:cNvPr id="26" name="Text 24"/>
+          <p:cNvSpPr/>
+          <p:nvPr/>
+        </p:nvSpPr>
+        <p:spPr>
+          <a:xfrm>
+            <a:off x="5769864" y="3136392"/>
+            <a:ext cx="1417320" cy="384048"/>
           </a:xfrm>
           <a:prstGeom prst="rect">
             <a:avLst/>
@@ -1869,14 +1677,14 @@
       </p:sp>
       <p:sp>
         <p:nvSpPr>
-          <p:cNvPr id="33" name="Shape 31"/>
-          <p:cNvSpPr/>
-          <p:nvPr/>
-        </p:nvSpPr>
-        <p:spPr>
-          <a:xfrm>
-            <a:off x="7383780" y="3337560"/>
-            <a:ext cx="1508760" cy="347472"/>
+          <p:cNvPr id="27" name="Shape 25"/>
+          <p:cNvSpPr/>
+          <p:nvPr/>
+        </p:nvSpPr>
+        <p:spPr>
+          <a:xfrm>
+            <a:off x="7296912" y="3136392"/>
+            <a:ext cx="1417320" cy="384048"/>
           </a:xfrm>
           <a:prstGeom prst="rect">
             <a:avLst/>
@@ -1894,14 +1702,14 @@
       </p:sp>
       <p:sp>
         <p:nvSpPr>
-          <p:cNvPr id="34" name="Text 32"/>
-          <p:cNvSpPr/>
-          <p:nvPr/>
-        </p:nvSpPr>
-        <p:spPr>
-          <a:xfrm>
-            <a:off x="7383780" y="3337560"/>
-            <a:ext cx="1508760" cy="347472"/>
+          <p:cNvPr id="28" name="Text 26"/>
+          <p:cNvSpPr/>
+          <p:nvPr/>
+        </p:nvSpPr>
+        <p:spPr>
+          <a:xfrm>
+            <a:off x="7296912" y="3136392"/>
+            <a:ext cx="1417320" cy="384048"/>
           </a:xfrm>
           <a:prstGeom prst="rect">
             <a:avLst/>
@@ -1933,14 +1741,14 @@
       </p:sp>
       <p:sp>
         <p:nvSpPr>
-          <p:cNvPr id="35" name="Shape 33"/>
-          <p:cNvSpPr/>
-          <p:nvPr/>
-        </p:nvSpPr>
-        <p:spPr>
-          <a:xfrm>
-            <a:off x="457200" y="3931920"/>
-            <a:ext cx="8229600" cy="685800"/>
+          <p:cNvPr id="29" name="Shape 27"/>
+          <p:cNvSpPr/>
+          <p:nvPr/>
+        </p:nvSpPr>
+        <p:spPr>
+          <a:xfrm>
+            <a:off x="457200" y="3977640"/>
+            <a:ext cx="8229600" cy="731520"/>
           </a:xfrm>
           <a:prstGeom prst="rect">
             <a:avLst/>
@@ -1958,13 +1766,13 @@
       </p:sp>
       <p:sp>
         <p:nvSpPr>
-          <p:cNvPr id="36" name="Text 34"/>
-          <p:cNvSpPr/>
-          <p:nvPr/>
-        </p:nvSpPr>
-        <p:spPr>
-          <a:xfrm>
-            <a:off x="640080" y="3977640"/>
+          <p:cNvPr id="30" name="Text 28"/>
+          <p:cNvSpPr/>
+          <p:nvPr/>
+        </p:nvSpPr>
+        <p:spPr>
+          <a:xfrm>
+            <a:off x="640080" y="4032504"/>
             <a:ext cx="2560320" cy="274320"/>
           </a:xfrm>
           <a:prstGeom prst="rect">
@@ -1997,14 +1805,14 @@
       </p:sp>
       <p:sp>
         <p:nvSpPr>
-          <p:cNvPr id="37" name="Shape 35"/>
-          <p:cNvSpPr/>
-          <p:nvPr/>
-        </p:nvSpPr>
-        <p:spPr>
-          <a:xfrm>
-            <a:off x="2651760" y="4160520"/>
-            <a:ext cx="1920240" cy="347472"/>
+          <p:cNvPr id="31" name="Shape 29"/>
+          <p:cNvSpPr/>
+          <p:nvPr/>
+        </p:nvSpPr>
+        <p:spPr>
+          <a:xfrm>
+            <a:off x="2862072" y="4233672"/>
+            <a:ext cx="1828800" cy="384048"/>
           </a:xfrm>
           <a:prstGeom prst="rect">
             <a:avLst/>
@@ -2022,14 +1830,14 @@
       </p:sp>
       <p:sp>
         <p:nvSpPr>
-          <p:cNvPr id="38" name="Text 36"/>
-          <p:cNvSpPr/>
-          <p:nvPr/>
-        </p:nvSpPr>
-        <p:spPr>
-          <a:xfrm>
-            <a:off x="2651760" y="4160520"/>
-            <a:ext cx="1920240" cy="347472"/>
+          <p:cNvPr id="32" name="Text 30"/>
+          <p:cNvSpPr/>
+          <p:nvPr/>
+        </p:nvSpPr>
+        <p:spPr>
+          <a:xfrm>
+            <a:off x="2862072" y="4233672"/>
+            <a:ext cx="1828800" cy="384048"/>
           </a:xfrm>
           <a:prstGeom prst="rect">
             <a:avLst/>
@@ -2061,14 +1869,14 @@
       </p:sp>
       <p:sp>
         <p:nvSpPr>
-          <p:cNvPr id="39" name="Shape 37"/>
-          <p:cNvSpPr/>
-          <p:nvPr/>
-        </p:nvSpPr>
-        <p:spPr>
-          <a:xfrm>
-            <a:off x="4709160" y="4160520"/>
-            <a:ext cx="1920240" cy="347472"/>
+          <p:cNvPr id="33" name="Shape 31"/>
+          <p:cNvSpPr/>
+          <p:nvPr/>
+        </p:nvSpPr>
+        <p:spPr>
+          <a:xfrm>
+            <a:off x="4800600" y="4233672"/>
+            <a:ext cx="1828800" cy="384048"/>
           </a:xfrm>
           <a:prstGeom prst="rect">
             <a:avLst/>
@@ -2086,14 +1894,14 @@
       </p:sp>
       <p:sp>
         <p:nvSpPr>
-          <p:cNvPr id="40" name="Text 38"/>
-          <p:cNvSpPr/>
-          <p:nvPr/>
-        </p:nvSpPr>
-        <p:spPr>
-          <a:xfrm>
-            <a:off x="4709160" y="4160520"/>
-            <a:ext cx="1920240" cy="347472"/>
+          <p:cNvPr id="34" name="Text 32"/>
+          <p:cNvSpPr/>
+          <p:nvPr/>
+        </p:nvSpPr>
+        <p:spPr>
+          <a:xfrm>
+            <a:off x="4800600" y="4233672"/>
+            <a:ext cx="1828800" cy="384048"/>
           </a:xfrm>
           <a:prstGeom prst="rect">
             <a:avLst/>
@@ -2125,14 +1933,14 @@
       </p:sp>
       <p:sp>
         <p:nvSpPr>
-          <p:cNvPr id="41" name="Shape 39"/>
-          <p:cNvSpPr/>
-          <p:nvPr/>
-        </p:nvSpPr>
-        <p:spPr>
-          <a:xfrm>
-            <a:off x="6766560" y="4160520"/>
-            <a:ext cx="1920240" cy="347472"/>
+          <p:cNvPr id="35" name="Shape 33"/>
+          <p:cNvSpPr/>
+          <p:nvPr/>
+        </p:nvSpPr>
+        <p:spPr>
+          <a:xfrm>
+            <a:off x="6739128" y="4233672"/>
+            <a:ext cx="1828800" cy="384048"/>
           </a:xfrm>
           <a:prstGeom prst="rect">
             <a:avLst/>
@@ -2150,14 +1958,14 @@
       </p:sp>
       <p:sp>
         <p:nvSpPr>
-          <p:cNvPr id="42" name="Text 40"/>
-          <p:cNvSpPr/>
-          <p:nvPr/>
-        </p:nvSpPr>
-        <p:spPr>
-          <a:xfrm>
-            <a:off x="6766560" y="4160520"/>
-            <a:ext cx="1920240" cy="347472"/>
+          <p:cNvPr id="36" name="Text 34"/>
+          <p:cNvSpPr/>
+          <p:nvPr/>
+        </p:nvSpPr>
+        <p:spPr>
+          <a:xfrm>
+            <a:off x="6739128" y="4233672"/>
+            <a:ext cx="1828800" cy="384048"/>
           </a:xfrm>
           <a:prstGeom prst="rect">
             <a:avLst/>
@@ -2189,14 +1997,14 @@
       </p:sp>
       <p:sp>
         <p:nvSpPr>
-          <p:cNvPr id="43" name="Shape 41"/>
-          <p:cNvSpPr/>
-          <p:nvPr/>
-        </p:nvSpPr>
-        <p:spPr>
-          <a:xfrm>
-            <a:off x="4110228" y="1325880"/>
-            <a:ext cx="9144" cy="68580"/>
+          <p:cNvPr id="37" name="Shape 35"/>
+          <p:cNvSpPr/>
+          <p:nvPr/>
+        </p:nvSpPr>
+        <p:spPr>
+          <a:xfrm>
+            <a:off x="4110228" y="1417320"/>
+            <a:ext cx="9144" cy="182880"/>
           </a:xfrm>
           <a:prstGeom prst="rect">
             <a:avLst/>
@@ -2214,13 +2022,13 @@
       </p:sp>
       <p:sp>
         <p:nvSpPr>
-          <p:cNvPr id="44" name="Shape 42"/>
+          <p:cNvPr id="38" name="Shape 36"/>
           <p:cNvSpPr/>
           <p:nvPr/>
         </p:nvSpPr>
         <p:spPr>
           <a:xfrm rot="10800000">
-            <a:off x="4041648" y="1321308"/>
+            <a:off x="4041648" y="1527048"/>
             <a:ext cx="146304" cy="91440"/>
           </a:xfrm>
           <a:prstGeom prst="triangle">
@@ -2239,13 +2047,13 @@
       </p:sp>
       <p:sp>
         <p:nvSpPr>
-          <p:cNvPr id="45" name="Text 43"/>
-          <p:cNvSpPr/>
-          <p:nvPr/>
-        </p:nvSpPr>
-        <p:spPr>
-          <a:xfrm>
-            <a:off x="3520440" y="1325880"/>
+          <p:cNvPr id="39" name="Text 37"/>
+          <p:cNvSpPr/>
+          <p:nvPr/>
+        </p:nvSpPr>
+        <p:spPr>
+          <a:xfrm>
+            <a:off x="3520440" y="1417320"/>
             <a:ext cx="502920" cy="201168"/>
           </a:xfrm>
           <a:prstGeom prst="rect">
@@ -2278,14 +2086,14 @@
       </p:sp>
       <p:sp>
         <p:nvSpPr>
-          <p:cNvPr id="46" name="Shape 44"/>
-          <p:cNvSpPr/>
-          <p:nvPr/>
-        </p:nvSpPr>
-        <p:spPr>
-          <a:xfrm>
-            <a:off x="4658868" y="1394460"/>
-            <a:ext cx="9144" cy="68580"/>
+          <p:cNvPr id="40" name="Shape 38"/>
+          <p:cNvSpPr/>
+          <p:nvPr/>
+        </p:nvSpPr>
+        <p:spPr>
+          <a:xfrm>
+            <a:off x="4658868" y="1600200"/>
+            <a:ext cx="9144" cy="182880"/>
           </a:xfrm>
           <a:prstGeom prst="rect">
             <a:avLst/>
@@ -2303,13 +2111,13 @@
       </p:sp>
       <p:sp>
         <p:nvSpPr>
-          <p:cNvPr id="47" name="Shape 45"/>
-          <p:cNvSpPr/>
-          <p:nvPr/>
-        </p:nvSpPr>
-        <p:spPr>
-          <a:xfrm>
-            <a:off x="4590288" y="1325880"/>
+          <p:cNvPr id="41" name="Shape 39"/>
+          <p:cNvSpPr/>
+          <p:nvPr/>
+        </p:nvSpPr>
+        <p:spPr>
+          <a:xfrm>
+            <a:off x="4590288" y="1417320"/>
             <a:ext cx="146304" cy="91440"/>
           </a:xfrm>
           <a:prstGeom prst="triangle">
@@ -2328,13 +2136,13 @@
       </p:sp>
       <p:sp>
         <p:nvSpPr>
-          <p:cNvPr id="48" name="Text 46"/>
-          <p:cNvSpPr/>
-          <p:nvPr/>
-        </p:nvSpPr>
-        <p:spPr>
-          <a:xfrm>
-            <a:off x="5166360" y="1325880"/>
+          <p:cNvPr id="42" name="Text 40"/>
+          <p:cNvSpPr/>
+          <p:nvPr/>
+        </p:nvSpPr>
+        <p:spPr>
+          <a:xfrm>
+            <a:off x="5166360" y="1417320"/>
             <a:ext cx="502920" cy="201168"/>
           </a:xfrm>
           <a:prstGeom prst="rect">
@@ -2367,14 +2175,14 @@
       </p:sp>
       <p:sp>
         <p:nvSpPr>
-          <p:cNvPr id="49" name="Shape 47"/>
-          <p:cNvSpPr/>
-          <p:nvPr/>
-        </p:nvSpPr>
-        <p:spPr>
-          <a:xfrm>
-            <a:off x="4110228" y="2148840"/>
-            <a:ext cx="9144" cy="68580"/>
+          <p:cNvPr id="43" name="Shape 41"/>
+          <p:cNvSpPr/>
+          <p:nvPr/>
+        </p:nvSpPr>
+        <p:spPr>
+          <a:xfrm>
+            <a:off x="4110228" y="2514600"/>
+            <a:ext cx="9144" cy="182880"/>
           </a:xfrm>
           <a:prstGeom prst="rect">
             <a:avLst/>
@@ -2392,13 +2200,13 @@
       </p:sp>
       <p:sp>
         <p:nvSpPr>
-          <p:cNvPr id="50" name="Shape 48"/>
+          <p:cNvPr id="44" name="Shape 42"/>
           <p:cNvSpPr/>
           <p:nvPr/>
         </p:nvSpPr>
         <p:spPr>
           <a:xfrm rot="10800000">
-            <a:off x="4041648" y="2144268"/>
+            <a:off x="4041648" y="2624328"/>
             <a:ext cx="146304" cy="91440"/>
           </a:xfrm>
           <a:prstGeom prst="triangle">
@@ -2417,13 +2225,13 @@
       </p:sp>
       <p:sp>
         <p:nvSpPr>
-          <p:cNvPr id="51" name="Text 49"/>
-          <p:cNvSpPr/>
-          <p:nvPr/>
-        </p:nvSpPr>
-        <p:spPr>
-          <a:xfrm>
-            <a:off x="3520440" y="2148840"/>
+          <p:cNvPr id="45" name="Text 43"/>
+          <p:cNvSpPr/>
+          <p:nvPr/>
+        </p:nvSpPr>
+        <p:spPr>
+          <a:xfrm>
+            <a:off x="3520440" y="2514600"/>
             <a:ext cx="502920" cy="201168"/>
           </a:xfrm>
           <a:prstGeom prst="rect">
@@ -2456,14 +2264,14 @@
       </p:sp>
       <p:sp>
         <p:nvSpPr>
-          <p:cNvPr id="52" name="Shape 50"/>
-          <p:cNvSpPr/>
-          <p:nvPr/>
-        </p:nvSpPr>
-        <p:spPr>
-          <a:xfrm>
-            <a:off x="4658868" y="2217420"/>
-            <a:ext cx="9144" cy="68580"/>
+          <p:cNvPr id="46" name="Shape 44"/>
+          <p:cNvSpPr/>
+          <p:nvPr/>
+        </p:nvSpPr>
+        <p:spPr>
+          <a:xfrm>
+            <a:off x="4658868" y="2697480"/>
+            <a:ext cx="9144" cy="182880"/>
           </a:xfrm>
           <a:prstGeom prst="rect">
             <a:avLst/>
@@ -2481,13 +2289,13 @@
       </p:sp>
       <p:sp>
         <p:nvSpPr>
-          <p:cNvPr id="53" name="Shape 51"/>
-          <p:cNvSpPr/>
-          <p:nvPr/>
-        </p:nvSpPr>
-        <p:spPr>
-          <a:xfrm>
-            <a:off x="4590288" y="2148840"/>
+          <p:cNvPr id="47" name="Shape 45"/>
+          <p:cNvSpPr/>
+          <p:nvPr/>
+        </p:nvSpPr>
+        <p:spPr>
+          <a:xfrm>
+            <a:off x="4590288" y="2514600"/>
             <a:ext cx="146304" cy="91440"/>
           </a:xfrm>
           <a:prstGeom prst="triangle">
@@ -2506,13 +2314,13 @@
       </p:sp>
       <p:sp>
         <p:nvSpPr>
-          <p:cNvPr id="54" name="Text 52"/>
-          <p:cNvSpPr/>
-          <p:nvPr/>
-        </p:nvSpPr>
-        <p:spPr>
-          <a:xfrm>
-            <a:off x="5166360" y="2148840"/>
+          <p:cNvPr id="48" name="Text 46"/>
+          <p:cNvSpPr/>
+          <p:nvPr/>
+        </p:nvSpPr>
+        <p:spPr>
+          <a:xfrm>
+            <a:off x="5166360" y="2514600"/>
             <a:ext cx="502920" cy="201168"/>
           </a:xfrm>
           <a:prstGeom prst="rect">
@@ -2545,14 +2353,14 @@
       </p:sp>
       <p:sp>
         <p:nvSpPr>
-          <p:cNvPr id="55" name="Shape 53"/>
-          <p:cNvSpPr/>
-          <p:nvPr/>
-        </p:nvSpPr>
-        <p:spPr>
-          <a:xfrm>
-            <a:off x="4110228" y="2971800"/>
-            <a:ext cx="9144" cy="68580"/>
+          <p:cNvPr id="49" name="Shape 47"/>
+          <p:cNvSpPr/>
+          <p:nvPr/>
+        </p:nvSpPr>
+        <p:spPr>
+          <a:xfrm>
+            <a:off x="4110228" y="3611880"/>
+            <a:ext cx="9144" cy="182880"/>
           </a:xfrm>
           <a:prstGeom prst="rect">
             <a:avLst/>
@@ -2570,13 +2378,13 @@
       </p:sp>
       <p:sp>
         <p:nvSpPr>
-          <p:cNvPr id="56" name="Shape 54"/>
+          <p:cNvPr id="50" name="Shape 48"/>
           <p:cNvSpPr/>
           <p:nvPr/>
         </p:nvSpPr>
         <p:spPr>
           <a:xfrm rot="10800000">
-            <a:off x="4041648" y="2967228"/>
+            <a:off x="4041648" y="3721608"/>
             <a:ext cx="146304" cy="91440"/>
           </a:xfrm>
           <a:prstGeom prst="triangle">
@@ -2595,13 +2403,13 @@
       </p:sp>
       <p:sp>
         <p:nvSpPr>
-          <p:cNvPr id="57" name="Text 55"/>
-          <p:cNvSpPr/>
-          <p:nvPr/>
-        </p:nvSpPr>
-        <p:spPr>
-          <a:xfrm>
-            <a:off x="3520440" y="2971800"/>
+          <p:cNvPr id="51" name="Text 49"/>
+          <p:cNvSpPr/>
+          <p:nvPr/>
+        </p:nvSpPr>
+        <p:spPr>
+          <a:xfrm>
+            <a:off x="3520440" y="3611880"/>
             <a:ext cx="502920" cy="201168"/>
           </a:xfrm>
           <a:prstGeom prst="rect">
@@ -2634,14 +2442,14 @@
       </p:sp>
       <p:sp>
         <p:nvSpPr>
-          <p:cNvPr id="58" name="Shape 56"/>
-          <p:cNvSpPr/>
-          <p:nvPr/>
-        </p:nvSpPr>
-        <p:spPr>
-          <a:xfrm>
-            <a:off x="4658868" y="3040380"/>
-            <a:ext cx="9144" cy="68580"/>
+          <p:cNvPr id="52" name="Shape 50"/>
+          <p:cNvSpPr/>
+          <p:nvPr/>
+        </p:nvSpPr>
+        <p:spPr>
+          <a:xfrm>
+            <a:off x="4658868" y="3794760"/>
+            <a:ext cx="9144" cy="182880"/>
           </a:xfrm>
           <a:prstGeom prst="rect">
             <a:avLst/>
@@ -2659,13 +2467,13 @@
       </p:sp>
       <p:sp>
         <p:nvSpPr>
-          <p:cNvPr id="59" name="Shape 57"/>
-          <p:cNvSpPr/>
-          <p:nvPr/>
-        </p:nvSpPr>
-        <p:spPr>
-          <a:xfrm>
-            <a:off x="4590288" y="2971800"/>
+          <p:cNvPr id="53" name="Shape 51"/>
+          <p:cNvSpPr/>
+          <p:nvPr/>
+        </p:nvSpPr>
+        <p:spPr>
+          <a:xfrm>
+            <a:off x="4590288" y="3611880"/>
             <a:ext cx="146304" cy="91440"/>
           </a:xfrm>
           <a:prstGeom prst="triangle">
@@ -2684,191 +2492,13 @@
       </p:sp>
       <p:sp>
         <p:nvSpPr>
-          <p:cNvPr id="60" name="Text 58"/>
-          <p:cNvSpPr/>
-          <p:nvPr/>
-        </p:nvSpPr>
-        <p:spPr>
-          <a:xfrm>
-            <a:off x="5166360" y="2971800"/>
-            <a:ext cx="502920" cy="201168"/>
-          </a:xfrm>
-          <a:prstGeom prst="rect">
-            <a:avLst/>
-          </a:prstGeom>
-          <a:noFill/>
-          <a:ln/>
-        </p:spPr>
-        <p:txBody>
-          <a:bodyPr wrap="square" rtlCol="0" anchor="ctr"/>
-          <a:lstStyle/>
-          <a:p>
-            <a:pPr algn="ctr" indent="0" marL="0">
-              <a:buNone/>
-            </a:pPr>
-            <a:r>
-              <a:rPr lang="en-US" sz="700" dirty="0">
-                <a:solidFill>
-                  <a:srgbClr val="666666"/>
-                </a:solidFill>
-                <a:latin typeface="맑은 고딕" pitchFamily="34" charset="0"/>
-                <a:ea typeface="맑은 고딕" pitchFamily="34" charset="-122"/>
-                <a:cs typeface="맑은 고딕" pitchFamily="34" charset="-120"/>
-              </a:rPr>
-              <a:t>응답</a:t>
-            </a:r>
-            <a:endParaRPr lang="en-US" sz="700" dirty="0"/>
-          </a:p>
-        </p:txBody>
-      </p:sp>
-      <p:sp>
-        <p:nvSpPr>
-          <p:cNvPr id="61" name="Shape 59"/>
-          <p:cNvSpPr/>
-          <p:nvPr/>
-        </p:nvSpPr>
-        <p:spPr>
-          <a:xfrm>
-            <a:off x="4110228" y="3794760"/>
-            <a:ext cx="9144" cy="68580"/>
-          </a:xfrm>
-          <a:prstGeom prst="rect">
-            <a:avLst/>
-          </a:prstGeom>
-          <a:solidFill>
-            <a:srgbClr val="333333"/>
-          </a:solidFill>
-          <a:ln w="12700">
-            <a:solidFill>
-              <a:srgbClr val="333333"/>
-            </a:solidFill>
-            <a:prstDash val="solid"/>
-          </a:ln>
-        </p:spPr>
-      </p:sp>
-      <p:sp>
-        <p:nvSpPr>
-          <p:cNvPr id="62" name="Shape 60"/>
-          <p:cNvSpPr/>
-          <p:nvPr/>
-        </p:nvSpPr>
-        <p:spPr>
-          <a:xfrm rot="10800000">
-            <a:off x="4041648" y="3790188"/>
-            <a:ext cx="146304" cy="91440"/>
-          </a:xfrm>
-          <a:prstGeom prst="triangle">
-            <a:avLst/>
-          </a:prstGeom>
-          <a:solidFill>
-            <a:srgbClr val="333333"/>
-          </a:solidFill>
-          <a:ln w="6350">
-            <a:solidFill>
-              <a:srgbClr val="333333"/>
-            </a:solidFill>
-            <a:prstDash val="solid"/>
-          </a:ln>
-        </p:spPr>
-      </p:sp>
-      <p:sp>
-        <p:nvSpPr>
-          <p:cNvPr id="63" name="Text 61"/>
-          <p:cNvSpPr/>
-          <p:nvPr/>
-        </p:nvSpPr>
-        <p:spPr>
-          <a:xfrm>
-            <a:off x="3520440" y="3794760"/>
-            <a:ext cx="502920" cy="201168"/>
-          </a:xfrm>
-          <a:prstGeom prst="rect">
-            <a:avLst/>
-          </a:prstGeom>
-          <a:noFill/>
-          <a:ln/>
-        </p:spPr>
-        <p:txBody>
-          <a:bodyPr wrap="square" rtlCol="0" anchor="ctr"/>
-          <a:lstStyle/>
-          <a:p>
-            <a:pPr algn="ctr" indent="0" marL="0">
-              <a:buNone/>
-            </a:pPr>
-            <a:r>
-              <a:rPr lang="en-US" sz="700" dirty="0">
-                <a:solidFill>
-                  <a:srgbClr val="333333"/>
-                </a:solidFill>
-                <a:latin typeface="맑은 고딕" pitchFamily="34" charset="0"/>
-                <a:ea typeface="맑은 고딕" pitchFamily="34" charset="-122"/>
-                <a:cs typeface="맑은 고딕" pitchFamily="34" charset="-120"/>
-              </a:rPr>
-              <a:t>요청</a:t>
-            </a:r>
-            <a:endParaRPr lang="en-US" sz="700" dirty="0"/>
-          </a:p>
-        </p:txBody>
-      </p:sp>
-      <p:sp>
-        <p:nvSpPr>
-          <p:cNvPr id="64" name="Shape 62"/>
-          <p:cNvSpPr/>
-          <p:nvPr/>
-        </p:nvSpPr>
-        <p:spPr>
-          <a:xfrm>
-            <a:off x="4658868" y="3863340"/>
-            <a:ext cx="9144" cy="68580"/>
-          </a:xfrm>
-          <a:prstGeom prst="rect">
-            <a:avLst/>
-          </a:prstGeom>
-          <a:solidFill>
-            <a:srgbClr val="666666"/>
-          </a:solidFill>
-          <a:ln w="12700">
-            <a:solidFill>
-              <a:srgbClr val="333333"/>
-            </a:solidFill>
-            <a:prstDash val="solid"/>
-          </a:ln>
-        </p:spPr>
-      </p:sp>
-      <p:sp>
-        <p:nvSpPr>
-          <p:cNvPr id="65" name="Shape 63"/>
-          <p:cNvSpPr/>
-          <p:nvPr/>
-        </p:nvSpPr>
-        <p:spPr>
-          <a:xfrm>
-            <a:off x="4590288" y="3794760"/>
-            <a:ext cx="146304" cy="91440"/>
-          </a:xfrm>
-          <a:prstGeom prst="triangle">
-            <a:avLst/>
-          </a:prstGeom>
-          <a:solidFill>
-            <a:srgbClr val="666666"/>
-          </a:solidFill>
-          <a:ln w="6350">
-            <a:solidFill>
-              <a:srgbClr val="666666"/>
-            </a:solidFill>
-            <a:prstDash val="solid"/>
-          </a:ln>
-        </p:spPr>
-      </p:sp>
-      <p:sp>
-        <p:nvSpPr>
-          <p:cNvPr id="66" name="Text 64"/>
-          <p:cNvSpPr/>
-          <p:nvPr/>
-        </p:nvSpPr>
-        <p:spPr>
-          <a:xfrm>
-            <a:off x="5166360" y="3794760"/>
+          <p:cNvPr id="54" name="Text 52"/>
+          <p:cNvSpPr/>
+          <p:nvPr/>
+        </p:nvSpPr>
+        <p:spPr>
+          <a:xfrm>
+            <a:off x="5166360" y="3611880"/>
             <a:ext cx="502920" cy="201168"/>
           </a:xfrm>
           <a:prstGeom prst="rect">

</xml_diff>